<commit_message>
Replace 6 with 5
</commit_message>
<xml_diff>
--- a/Slides/Module 08 Code Level Design.pptx
+++ b/Slides/Module 08 Code Level Design.pptx
@@ -952,135 +952,6 @@
     </pc:docChg>
   </pc:docChgLst>
   <pc:docChgLst>
-    <pc:chgData name="Mitchell Wand" userId="de9b44c55c049659" providerId="LiveId" clId="{F51B1847-95FF-4053-B76F-28C840121525}"/>
-    <pc:docChg chg="addSld delSld modSld">
-      <pc:chgData name="Mitchell Wand" userId="de9b44c55c049659" providerId="LiveId" clId="{F51B1847-95FF-4053-B76F-28C840121525}" dt="2024-09-03T01:47:57.061" v="1644" actId="2696"/>
-      <pc:docMkLst>
-        <pc:docMk/>
-      </pc:docMkLst>
-      <pc:sldChg chg="addSp modSp mod modAnim modNotesTx">
-        <pc:chgData name="Mitchell Wand" userId="de9b44c55c049659" providerId="LiveId" clId="{F51B1847-95FF-4053-B76F-28C840121525}" dt="2024-09-03T01:34:55.374" v="592" actId="20577"/>
-        <pc:sldMkLst>
-          <pc:docMk/>
-          <pc:sldMk cId="657427070" sldId="496"/>
-        </pc:sldMkLst>
-        <pc:spChg chg="add mod">
-          <ac:chgData name="Mitchell Wand" userId="de9b44c55c049659" providerId="LiveId" clId="{F51B1847-95FF-4053-B76F-28C840121525}" dt="2024-09-03T01:26:59.280" v="3" actId="1076"/>
-          <ac:spMkLst>
-            <pc:docMk/>
-            <pc:sldMk cId="657427070" sldId="496"/>
-            <ac:spMk id="3" creationId="{273F088B-3B9A-8204-31DE-C59AFF5D341B}"/>
-          </ac:spMkLst>
-        </pc:spChg>
-      </pc:sldChg>
-      <pc:sldChg chg="modNotesTx">
-        <pc:chgData name="Mitchell Wand" userId="de9b44c55c049659" providerId="LiveId" clId="{F51B1847-95FF-4053-B76F-28C840121525}" dt="2024-09-03T01:36:52.326" v="818" actId="20577"/>
-        <pc:sldMkLst>
-          <pc:docMk/>
-          <pc:sldMk cId="1198500969" sldId="497"/>
-        </pc:sldMkLst>
-      </pc:sldChg>
-      <pc:sldChg chg="modNotesTx">
-        <pc:chgData name="Mitchell Wand" userId="de9b44c55c049659" providerId="LiveId" clId="{F51B1847-95FF-4053-B76F-28C840121525}" dt="2024-09-03T01:40:18.139" v="1144" actId="20577"/>
-        <pc:sldMkLst>
-          <pc:docMk/>
-          <pc:sldMk cId="2839435653" sldId="498"/>
-        </pc:sldMkLst>
-      </pc:sldChg>
-      <pc:sldChg chg="modNotesTx">
-        <pc:chgData name="Mitchell Wand" userId="de9b44c55c049659" providerId="LiveId" clId="{F51B1847-95FF-4053-B76F-28C840121525}" dt="2024-09-03T01:41:10.727" v="1279" actId="20577"/>
-        <pc:sldMkLst>
-          <pc:docMk/>
-          <pc:sldMk cId="4155274164" sldId="499"/>
-        </pc:sldMkLst>
-      </pc:sldChg>
-      <pc:sldChg chg="modNotesTx">
-        <pc:chgData name="Mitchell Wand" userId="de9b44c55c049659" providerId="LiveId" clId="{F51B1847-95FF-4053-B76F-28C840121525}" dt="2024-09-03T01:43:06.941" v="1351" actId="20577"/>
-        <pc:sldMkLst>
-          <pc:docMk/>
-          <pc:sldMk cId="1442055128" sldId="502"/>
-        </pc:sldMkLst>
-      </pc:sldChg>
-      <pc:sldChg chg="mod modShow">
-        <pc:chgData name="Mitchell Wand" userId="de9b44c55c049659" providerId="LiveId" clId="{F51B1847-95FF-4053-B76F-28C840121525}" dt="2024-09-03T01:37:08.739" v="819" actId="729"/>
-        <pc:sldMkLst>
-          <pc:docMk/>
-          <pc:sldMk cId="3512688338" sldId="504"/>
-        </pc:sldMkLst>
-      </pc:sldChg>
-      <pc:sldChg chg="modNotesTx">
-        <pc:chgData name="Mitchell Wand" userId="de9b44c55c049659" providerId="LiveId" clId="{F51B1847-95FF-4053-B76F-28C840121525}" dt="2024-09-03T01:46:00.977" v="1642" actId="20577"/>
-        <pc:sldMkLst>
-          <pc:docMk/>
-          <pc:sldMk cId="935629653" sldId="506"/>
-        </pc:sldMkLst>
-      </pc:sldChg>
-      <pc:sldChg chg="add del">
-        <pc:chgData name="Mitchell Wand" userId="de9b44c55c049659" providerId="LiveId" clId="{F51B1847-95FF-4053-B76F-28C840121525}" dt="2024-09-03T01:47:57.061" v="1644" actId="2696"/>
-        <pc:sldMkLst>
-          <pc:docMk/>
-          <pc:sldMk cId="3121632177" sldId="514"/>
-        </pc:sldMkLst>
-      </pc:sldChg>
-    </pc:docChg>
-  </pc:docChgLst>
-  <pc:docChgLst>
-    <pc:chgData name="Mitchell Wand" userId="de9b44c55c049659" providerId="LiveId" clId="{99718308-7C56-473B-8B2B-53B03B1B7395}"/>
-    <pc:docChg chg="undo custSel addSld modSld">
-      <pc:chgData name="Mitchell Wand" userId="de9b44c55c049659" providerId="LiveId" clId="{99718308-7C56-473B-8B2B-53B03B1B7395}" dt="2022-09-14T18:51:01.402" v="704" actId="27636"/>
-      <pc:docMkLst>
-        <pc:docMk/>
-      </pc:docMkLst>
-      <pc:sldChg chg="addSp modSp add mod modAnim modNotesTx">
-        <pc:chgData name="Mitchell Wand" userId="de9b44c55c049659" providerId="LiveId" clId="{99718308-7C56-473B-8B2B-53B03B1B7395}" dt="2022-09-14T18:51:01.402" v="704" actId="27636"/>
-        <pc:sldMkLst>
-          <pc:docMk/>
-          <pc:sldMk cId="3605028067" sldId="495"/>
-        </pc:sldMkLst>
-        <pc:spChg chg="mod">
-          <ac:chgData name="Mitchell Wand" userId="de9b44c55c049659" providerId="LiveId" clId="{99718308-7C56-473B-8B2B-53B03B1B7395}" dt="2022-09-14T18:40:45.997" v="75" actId="20577"/>
-          <ac:spMkLst>
-            <pc:docMk/>
-            <pc:sldMk cId="3605028067" sldId="495"/>
-            <ac:spMk id="2" creationId="{BA745527-D100-4B4F-829D-1B696CAF1C9B}"/>
-          </ac:spMkLst>
-        </pc:spChg>
-        <pc:spChg chg="mod">
-          <ac:chgData name="Mitchell Wand" userId="de9b44c55c049659" providerId="LiveId" clId="{99718308-7C56-473B-8B2B-53B03B1B7395}" dt="2022-09-14T18:51:01.402" v="704" actId="27636"/>
-          <ac:spMkLst>
-            <pc:docMk/>
-            <pc:sldMk cId="3605028067" sldId="495"/>
-            <ac:spMk id="3" creationId="{FCCE4D6C-6E60-4E4C-BE55-5674B33BAD01}"/>
-          </ac:spMkLst>
-        </pc:spChg>
-        <pc:spChg chg="mod">
-          <ac:chgData name="Mitchell Wand" userId="de9b44c55c049659" providerId="LiveId" clId="{99718308-7C56-473B-8B2B-53B03B1B7395}" dt="2022-09-14T18:39:05.942" v="17" actId="255"/>
-          <ac:spMkLst>
-            <pc:docMk/>
-            <pc:sldMk cId="3605028067" sldId="495"/>
-            <ac:spMk id="5" creationId="{7A7CE241-579A-C00B-2C03-8055423915D5}"/>
-          </ac:spMkLst>
-        </pc:spChg>
-        <pc:spChg chg="mod">
-          <ac:chgData name="Mitchell Wand" userId="de9b44c55c049659" providerId="LiveId" clId="{99718308-7C56-473B-8B2B-53B03B1B7395}" dt="2022-09-14T18:39:17.321" v="20" actId="20577"/>
-          <ac:spMkLst>
-            <pc:docMk/>
-            <pc:sldMk cId="3605028067" sldId="495"/>
-            <ac:spMk id="6" creationId="{DDC06498-1D10-4E52-A107-990734307F51}"/>
-          </ac:spMkLst>
-        </pc:spChg>
-        <pc:spChg chg="add mod">
-          <ac:chgData name="Mitchell Wand" userId="de9b44c55c049659" providerId="LiveId" clId="{99718308-7C56-473B-8B2B-53B03B1B7395}" dt="2022-09-14T18:40:01.254" v="26" actId="255"/>
-          <ac:spMkLst>
-            <pc:docMk/>
-            <pc:sldMk cId="3605028067" sldId="495"/>
-            <ac:spMk id="11" creationId="{1B7168C4-C6D5-1024-A1FA-7A1C9E11C8D2}"/>
-          </ac:spMkLst>
-        </pc:spChg>
-      </pc:sldChg>
-    </pc:docChg>
-  </pc:docChgLst>
-  <pc:docChgLst>
     <pc:chgData name="Mitchell Wand" userId="de9b44c55c049659" providerId="LiveId" clId="{1B3D1EA2-D633-4A89-BCEE-7757CCB4FD42}"/>
     <pc:docChg chg="undo custSel modSld">
       <pc:chgData name="Mitchell Wand" userId="de9b44c55c049659" providerId="LiveId" clId="{1B3D1EA2-D633-4A89-BCEE-7757CCB4FD42}" dt="2023-01-07T17:13:38.282" v="157" actId="20577"/>
@@ -1245,6 +1116,135 @@
         <pc:sldMkLst>
           <pc:docMk/>
           <pc:sldMk cId="3345968335" sldId="430"/>
+        </pc:sldMkLst>
+      </pc:sldChg>
+    </pc:docChg>
+  </pc:docChgLst>
+  <pc:docChgLst>
+    <pc:chgData name="Mitchell Wand" userId="de9b44c55c049659" providerId="LiveId" clId="{99718308-7C56-473B-8B2B-53B03B1B7395}"/>
+    <pc:docChg chg="undo custSel addSld modSld">
+      <pc:chgData name="Mitchell Wand" userId="de9b44c55c049659" providerId="LiveId" clId="{99718308-7C56-473B-8B2B-53B03B1B7395}" dt="2022-09-14T18:51:01.402" v="704" actId="27636"/>
+      <pc:docMkLst>
+        <pc:docMk/>
+      </pc:docMkLst>
+      <pc:sldChg chg="addSp modSp add mod modAnim modNotesTx">
+        <pc:chgData name="Mitchell Wand" userId="de9b44c55c049659" providerId="LiveId" clId="{99718308-7C56-473B-8B2B-53B03B1B7395}" dt="2022-09-14T18:51:01.402" v="704" actId="27636"/>
+        <pc:sldMkLst>
+          <pc:docMk/>
+          <pc:sldMk cId="3605028067" sldId="495"/>
+        </pc:sldMkLst>
+        <pc:spChg chg="mod">
+          <ac:chgData name="Mitchell Wand" userId="de9b44c55c049659" providerId="LiveId" clId="{99718308-7C56-473B-8B2B-53B03B1B7395}" dt="2022-09-14T18:40:45.997" v="75" actId="20577"/>
+          <ac:spMkLst>
+            <pc:docMk/>
+            <pc:sldMk cId="3605028067" sldId="495"/>
+            <ac:spMk id="2" creationId="{BA745527-D100-4B4F-829D-1B696CAF1C9B}"/>
+          </ac:spMkLst>
+        </pc:spChg>
+        <pc:spChg chg="mod">
+          <ac:chgData name="Mitchell Wand" userId="de9b44c55c049659" providerId="LiveId" clId="{99718308-7C56-473B-8B2B-53B03B1B7395}" dt="2022-09-14T18:51:01.402" v="704" actId="27636"/>
+          <ac:spMkLst>
+            <pc:docMk/>
+            <pc:sldMk cId="3605028067" sldId="495"/>
+            <ac:spMk id="3" creationId="{FCCE4D6C-6E60-4E4C-BE55-5674B33BAD01}"/>
+          </ac:spMkLst>
+        </pc:spChg>
+        <pc:spChg chg="mod">
+          <ac:chgData name="Mitchell Wand" userId="de9b44c55c049659" providerId="LiveId" clId="{99718308-7C56-473B-8B2B-53B03B1B7395}" dt="2022-09-14T18:39:05.942" v="17" actId="255"/>
+          <ac:spMkLst>
+            <pc:docMk/>
+            <pc:sldMk cId="3605028067" sldId="495"/>
+            <ac:spMk id="5" creationId="{7A7CE241-579A-C00B-2C03-8055423915D5}"/>
+          </ac:spMkLst>
+        </pc:spChg>
+        <pc:spChg chg="mod">
+          <ac:chgData name="Mitchell Wand" userId="de9b44c55c049659" providerId="LiveId" clId="{99718308-7C56-473B-8B2B-53B03B1B7395}" dt="2022-09-14T18:39:17.321" v="20" actId="20577"/>
+          <ac:spMkLst>
+            <pc:docMk/>
+            <pc:sldMk cId="3605028067" sldId="495"/>
+            <ac:spMk id="6" creationId="{DDC06498-1D10-4E52-A107-990734307F51}"/>
+          </ac:spMkLst>
+        </pc:spChg>
+        <pc:spChg chg="add mod">
+          <ac:chgData name="Mitchell Wand" userId="de9b44c55c049659" providerId="LiveId" clId="{99718308-7C56-473B-8B2B-53B03B1B7395}" dt="2022-09-14T18:40:01.254" v="26" actId="255"/>
+          <ac:spMkLst>
+            <pc:docMk/>
+            <pc:sldMk cId="3605028067" sldId="495"/>
+            <ac:spMk id="11" creationId="{1B7168C4-C6D5-1024-A1FA-7A1C9E11C8D2}"/>
+          </ac:spMkLst>
+        </pc:spChg>
+      </pc:sldChg>
+    </pc:docChg>
+  </pc:docChgLst>
+  <pc:docChgLst>
+    <pc:chgData name="Mitchell Wand" userId="de9b44c55c049659" providerId="LiveId" clId="{F51B1847-95FF-4053-B76F-28C840121525}"/>
+    <pc:docChg chg="addSld delSld modSld">
+      <pc:chgData name="Mitchell Wand" userId="de9b44c55c049659" providerId="LiveId" clId="{F51B1847-95FF-4053-B76F-28C840121525}" dt="2024-09-03T01:47:57.061" v="1644" actId="2696"/>
+      <pc:docMkLst>
+        <pc:docMk/>
+      </pc:docMkLst>
+      <pc:sldChg chg="addSp modSp mod modAnim modNotesTx">
+        <pc:chgData name="Mitchell Wand" userId="de9b44c55c049659" providerId="LiveId" clId="{F51B1847-95FF-4053-B76F-28C840121525}" dt="2024-09-03T01:34:55.374" v="592" actId="20577"/>
+        <pc:sldMkLst>
+          <pc:docMk/>
+          <pc:sldMk cId="657427070" sldId="496"/>
+        </pc:sldMkLst>
+        <pc:spChg chg="add mod">
+          <ac:chgData name="Mitchell Wand" userId="de9b44c55c049659" providerId="LiveId" clId="{F51B1847-95FF-4053-B76F-28C840121525}" dt="2024-09-03T01:26:59.280" v="3" actId="1076"/>
+          <ac:spMkLst>
+            <pc:docMk/>
+            <pc:sldMk cId="657427070" sldId="496"/>
+            <ac:spMk id="3" creationId="{273F088B-3B9A-8204-31DE-C59AFF5D341B}"/>
+          </ac:spMkLst>
+        </pc:spChg>
+      </pc:sldChg>
+      <pc:sldChg chg="modNotesTx">
+        <pc:chgData name="Mitchell Wand" userId="de9b44c55c049659" providerId="LiveId" clId="{F51B1847-95FF-4053-B76F-28C840121525}" dt="2024-09-03T01:36:52.326" v="818" actId="20577"/>
+        <pc:sldMkLst>
+          <pc:docMk/>
+          <pc:sldMk cId="1198500969" sldId="497"/>
+        </pc:sldMkLst>
+      </pc:sldChg>
+      <pc:sldChg chg="modNotesTx">
+        <pc:chgData name="Mitchell Wand" userId="de9b44c55c049659" providerId="LiveId" clId="{F51B1847-95FF-4053-B76F-28C840121525}" dt="2024-09-03T01:40:18.139" v="1144" actId="20577"/>
+        <pc:sldMkLst>
+          <pc:docMk/>
+          <pc:sldMk cId="2839435653" sldId="498"/>
+        </pc:sldMkLst>
+      </pc:sldChg>
+      <pc:sldChg chg="modNotesTx">
+        <pc:chgData name="Mitchell Wand" userId="de9b44c55c049659" providerId="LiveId" clId="{F51B1847-95FF-4053-B76F-28C840121525}" dt="2024-09-03T01:41:10.727" v="1279" actId="20577"/>
+        <pc:sldMkLst>
+          <pc:docMk/>
+          <pc:sldMk cId="4155274164" sldId="499"/>
+        </pc:sldMkLst>
+      </pc:sldChg>
+      <pc:sldChg chg="modNotesTx">
+        <pc:chgData name="Mitchell Wand" userId="de9b44c55c049659" providerId="LiveId" clId="{F51B1847-95FF-4053-B76F-28C840121525}" dt="2024-09-03T01:43:06.941" v="1351" actId="20577"/>
+        <pc:sldMkLst>
+          <pc:docMk/>
+          <pc:sldMk cId="1442055128" sldId="502"/>
+        </pc:sldMkLst>
+      </pc:sldChg>
+      <pc:sldChg chg="mod modShow">
+        <pc:chgData name="Mitchell Wand" userId="de9b44c55c049659" providerId="LiveId" clId="{F51B1847-95FF-4053-B76F-28C840121525}" dt="2024-09-03T01:37:08.739" v="819" actId="729"/>
+        <pc:sldMkLst>
+          <pc:docMk/>
+          <pc:sldMk cId="3512688338" sldId="504"/>
+        </pc:sldMkLst>
+      </pc:sldChg>
+      <pc:sldChg chg="modNotesTx">
+        <pc:chgData name="Mitchell Wand" userId="de9b44c55c049659" providerId="LiveId" clId="{F51B1847-95FF-4053-B76F-28C840121525}" dt="2024-09-03T01:46:00.977" v="1642" actId="20577"/>
+        <pc:sldMkLst>
+          <pc:docMk/>
+          <pc:sldMk cId="935629653" sldId="506"/>
+        </pc:sldMkLst>
+      </pc:sldChg>
+      <pc:sldChg chg="add del">
+        <pc:chgData name="Mitchell Wand" userId="de9b44c55c049659" providerId="LiveId" clId="{F51B1847-95FF-4053-B76F-28C840121525}" dt="2024-09-03T01:47:57.061" v="1644" actId="2696"/>
+        <pc:sldMkLst>
+          <pc:docMk/>
+          <pc:sldMk cId="3121632177" sldId="514"/>
         </pc:sldMkLst>
       </pc:sldChg>
     </pc:docChg>
@@ -7752,7 +7752,7 @@
           <a:p>
             <a:fld id="{7C7E5181-6CF5-45F7-A87A-E0E0B1FD7549}" type="datetimeFigureOut">
               <a:rPr lang="en-US" smtClean="0"/>
-              <a:t>1/26/26</a:t>
+              <a:t>1/28/26</a:t>
             </a:fld>
             <a:endParaRPr lang="en-US"/>
           </a:p>
@@ -13716,7 +13716,7 @@
           <a:p>
             <a:fld id="{5D2A64DE-480B-420F-9649-4F8E696E08E0}" type="datetime1">
               <a:rPr lang="en-US" smtClean="0"/>
-              <a:t>1/26/26</a:t>
+              <a:t>1/28/26</a:t>
             </a:fld>
             <a:endParaRPr lang="en-US"/>
           </a:p>
@@ -13950,7 +13950,7 @@
           <a:p>
             <a:fld id="{0D3616D0-8311-4107-9726-6B805E7D05BA}" type="datetime1">
               <a:rPr lang="en-US" smtClean="0"/>
-              <a:t>1/26/26</a:t>
+              <a:t>1/28/26</a:t>
             </a:fld>
             <a:endParaRPr lang="en-US"/>
           </a:p>
@@ -14158,7 +14158,7 @@
           <a:p>
             <a:fld id="{3BC2557A-5C88-417A-A763-5AC779462A5F}" type="datetime1">
               <a:rPr lang="en-US" smtClean="0"/>
-              <a:t>1/26/26</a:t>
+              <a:t>1/28/26</a:t>
             </a:fld>
             <a:endParaRPr lang="en-US"/>
           </a:p>
@@ -14713,7 +14713,7 @@
           <a:p>
             <a:fld id="{07C7BFD4-467E-4EDE-93EA-052F5B39A4E5}" type="datetime1">
               <a:rPr lang="en-US" smtClean="0"/>
-              <a:t>1/26/26</a:t>
+              <a:t>1/28/26</a:t>
             </a:fld>
             <a:endParaRPr lang="en-US"/>
           </a:p>
@@ -15026,7 +15026,7 @@
           <a:p>
             <a:fld id="{A533CBE2-D5BE-47AC-ADC2-9CDFC1D0CF90}" type="datetime1">
               <a:rPr lang="en-US" smtClean="0"/>
-              <a:t>1/26/26</a:t>
+              <a:t>1/28/26</a:t>
             </a:fld>
             <a:endParaRPr lang="en-US"/>
           </a:p>
@@ -15327,7 +15327,7 @@
           <a:p>
             <a:fld id="{39B7EDB1-CE74-4951-85A2-0B01C2128E28}" type="datetime1">
               <a:rPr lang="en-US" smtClean="0"/>
-              <a:t>1/26/26</a:t>
+              <a:t>1/28/26</a:t>
             </a:fld>
             <a:endParaRPr lang="en-US"/>
           </a:p>
@@ -15775,7 +15775,7 @@
           <a:p>
             <a:fld id="{2BC7EB92-A5C2-4807-A9DC-9EDE6CBFB241}" type="datetime1">
               <a:rPr lang="en-US" smtClean="0"/>
-              <a:t>1/26/26</a:t>
+              <a:t>1/28/26</a:t>
             </a:fld>
             <a:endParaRPr lang="en-US"/>
           </a:p>
@@ -15921,7 +15921,7 @@
           <a:p>
             <a:fld id="{109E55A0-C911-4F03-82FC-7E5926047D46}" type="datetime1">
               <a:rPr lang="en-US" smtClean="0"/>
-              <a:t>1/26/26</a:t>
+              <a:t>1/28/26</a:t>
             </a:fld>
             <a:endParaRPr lang="en-US"/>
           </a:p>
@@ -16070,7 +16070,7 @@
           <a:p>
             <a:fld id="{2B7B7EE0-7771-4CD5-9B2B-3550753A54A1}" type="datetime1">
               <a:rPr lang="en-US" smtClean="0"/>
-              <a:t>1/26/26</a:t>
+              <a:t>1/28/26</a:t>
             </a:fld>
             <a:endParaRPr lang="en-US"/>
           </a:p>
@@ -16381,7 +16381,7 @@
           <a:p>
             <a:fld id="{F8B318B3-0E87-4416-A9B8-D891968C2727}" type="datetime1">
               <a:rPr lang="en-US" smtClean="0"/>
-              <a:t>1/26/26</a:t>
+              <a:t>1/28/26</a:t>
             </a:fld>
             <a:endParaRPr lang="en-US"/>
           </a:p>
@@ -16669,7 +16669,7 @@
           <a:p>
             <a:fld id="{EA476A42-A091-4468-A075-64A31BE59948}" type="datetime1">
               <a:rPr lang="en-US" smtClean="0"/>
-              <a:t>1/26/26</a:t>
+              <a:t>1/28/26</a:t>
             </a:fld>
             <a:endParaRPr lang="en-US"/>
           </a:p>
@@ -16910,7 +16910,7 @@
           <a:p>
             <a:fld id="{54D997E8-DDEE-43F1-8D9B-F8A1E11DE488}" type="datetime1">
               <a:rPr lang="en-US" smtClean="0"/>
-              <a:t>1/26/26</a:t>
+              <a:t>1/28/26</a:t>
             </a:fld>
             <a:endParaRPr lang="en-US"/>
           </a:p>
@@ -21045,7 +21045,7 @@
           </a:ln>
           <a:extLst>
             <a:ext uri="{C572A759-6A51-4108-AA02-DFA0A04FC94B}">
-              <ma14:wrappingTextBoxFlag xmlns="" xmlns:m="http://schemas.openxmlformats.org/officeDocument/2006/math" xmlns:a14="http://schemas.microsoft.com/office/drawing/2010/main" xmlns:ma14="http://schemas.microsoft.com/office/mac/drawingml/2011/main" val="1"/>
+              <ma14:wrappingTextBoxFlag xmlns:ma14="http://schemas.microsoft.com/office/mac/drawingml/2011/main" xmlns:a14="http://schemas.microsoft.com/office/drawing/2010/main" xmlns:m="http://schemas.openxmlformats.org/officeDocument/2006/math" xmlns="" val="1"/>
             </a:ext>
           </a:extLst>
         </p:spPr>
@@ -23999,7 +23999,7 @@
             <a:pPr lvl="1" fontAlgn="base"/>
             <a:r>
               <a:rPr lang="en-US" dirty="0"/>
-              <a:t>List 6 principles for writing readable code, with examples</a:t>
+              <a:t>List 5 principles for writing readable code, with examples</a:t>
             </a:r>
           </a:p>
           <a:p>

</xml_diff>